<commit_message>
docs: adiciona checklist final na apresentacao e roteiro da gravacao
Ultimo slide lista os 29 itens do checklist do enunciado, com os
cumpridos marcados e os pendentes (video, link no README, envio no
AVA) sinalizados. O guia ganha o roteiro de uma tomada so no OBS:
apresentacao com tempo por slide para caber em 5 min e, em seguida,
a demonstracao ao vivo dos arquivos reais do projeto.

Co-Authored-By: Claude Opus 5.5 <noreply@anthropic.com>
</commit_message>
<xml_diff>
--- a/SalesInsight_PY.pptx
+++ b/SalesInsight_PY.pptx
@@ -25,6 +25,7 @@
     <p:sldId id="273" r:id="rId24"/>
     <p:sldId id="274" r:id="rId25"/>
     <p:sldId id="275" r:id="rId26"/>
+    <p:sldId id="276" r:id="rId27"/>
   </p:sldIdLst>
   <p:sldSz cx="12191695" cy="6858000" type="screen4x3"/>
   <p:notesSz cx="6858000" cy="9144000"/>
@@ -7193,6 +7194,1701 @@
             </a:pPr>
             <a:r>
               <a:t>Obrigado!</a:t>
+            </a:r>
+          </a:p>
+        </p:txBody>
+      </p:sp>
+    </p:spTree>
+  </p:cSld>
+  <p:clrMapOvr>
+    <a:masterClrMapping/>
+  </p:clrMapOvr>
+</p:sld>
+</file>
+
+<file path=ppt/slides/slide21.xml><?xml version="1.0" encoding="utf-8"?>
+<p:sld xmlns:a="http://schemas.openxmlformats.org/drawingml/2006/main" xmlns:p="http://schemas.openxmlformats.org/presentationml/2006/main" xmlns:r="http://schemas.openxmlformats.org/officeDocument/2006/relationships">
+  <p:cSld>
+    <p:spTree>
+      <p:nvGrpSpPr>
+        <p:cNvPr id="1" name=""/>
+        <p:cNvGrpSpPr/>
+        <p:nvPr/>
+      </p:nvGrpSpPr>
+      <p:grpSpPr/>
+      <p:sp>
+        <p:nvSpPr>
+          <p:cNvPr id="2" name="TextBox 1"/>
+          <p:cNvSpPr txBox="1"/>
+          <p:nvPr/>
+        </p:nvSpPr>
+        <p:spPr>
+          <a:xfrm>
+            <a:off x="457200" y="228600"/>
+            <a:ext cx="11277295" cy="822960"/>
+          </a:xfrm>
+          <a:prstGeom prst="rect">
+            <a:avLst/>
+          </a:prstGeom>
+          <a:noFill/>
+        </p:spPr>
+        <p:txBody>
+          <a:bodyPr wrap="square">
+            <a:spAutoFit/>
+          </a:bodyPr>
+          <a:lstStyle/>
+          <a:p>
+            <a:pPr>
+              <a:defRPr sz="2800" b="1">
+                <a:solidFill>
+                  <a:srgbClr val="1F4E79"/>
+                </a:solidFill>
+              </a:defRPr>
+            </a:pPr>
+            <a:r>
+              <a:t>Checklist final de entrega</a:t>
+            </a:r>
+          </a:p>
+          <a:p>
+            <a:pPr>
+              <a:defRPr sz="1300">
+                <a:solidFill>
+                  <a:srgbClr val="404040"/>
+                </a:solidFill>
+              </a:defRPr>
+            </a:pPr>
+            <a:r>
+              <a:t>Itens do enunciado (seção 6) — o que foi cumprido neste projeto</a:t>
+            </a:r>
+          </a:p>
+        </p:txBody>
+      </p:sp>
+      <p:sp>
+        <p:nvSpPr>
+          <p:cNvPr id="3" name="Rounded Rectangle 2"/>
+          <p:cNvSpPr/>
+          <p:nvPr/>
+        </p:nvSpPr>
+        <p:spPr>
+          <a:xfrm>
+            <a:off x="457200" y="1097280"/>
+            <a:ext cx="5501487" cy="310896"/>
+          </a:xfrm>
+          <a:prstGeom prst="roundRect">
+            <a:avLst/>
+          </a:prstGeom>
+          <a:solidFill>
+            <a:srgbClr val="EAF6EF"/>
+          </a:solidFill>
+          <a:ln w="12700">
+            <a:solidFill>
+              <a:srgbClr val="2E8B57"/>
+            </a:solidFill>
+          </a:ln>
+          <a:effectLst/>
+        </p:spPr>
+        <p:style>
+          <a:lnRef idx="1">
+            <a:schemeClr val="accent1"/>
+          </a:lnRef>
+          <a:fillRef idx="3">
+            <a:schemeClr val="accent1"/>
+          </a:fillRef>
+          <a:effectRef idx="2">
+            <a:schemeClr val="accent1"/>
+          </a:effectRef>
+          <a:fontRef idx="minor">
+            <a:schemeClr val="lt1"/>
+          </a:fontRef>
+        </p:style>
+        <p:txBody>
+          <a:bodyPr rtlCol="0" anchor="ctr" wrap="square" lIns="109728" rIns="73152" tIns="36576" bIns="36576"/>
+          <a:lstStyle/>
+          <a:p>
+            <a:pPr algn="ctr">
+              <a:defRPr sz="1150" b="1">
+                <a:solidFill>
+                  <a:srgbClr val="1E5E3C"/>
+                </a:solidFill>
+              </a:defRPr>
+            </a:pPr>
+            <a:r>
+              <a:t>✅ Repositório PÚBLICO no GitHub</a:t>
+            </a:r>
+          </a:p>
+        </p:txBody>
+      </p:sp>
+      <p:sp>
+        <p:nvSpPr>
+          <p:cNvPr id="4" name="Rounded Rectangle 3"/>
+          <p:cNvSpPr/>
+          <p:nvPr/>
+        </p:nvSpPr>
+        <p:spPr>
+          <a:xfrm>
+            <a:off x="6233007" y="1097280"/>
+            <a:ext cx="5501487" cy="310896"/>
+          </a:xfrm>
+          <a:prstGeom prst="roundRect">
+            <a:avLst/>
+          </a:prstGeom>
+          <a:solidFill>
+            <a:srgbClr val="EAF6EF"/>
+          </a:solidFill>
+          <a:ln w="12700">
+            <a:solidFill>
+              <a:srgbClr val="2E8B57"/>
+            </a:solidFill>
+          </a:ln>
+          <a:effectLst/>
+        </p:spPr>
+        <p:style>
+          <a:lnRef idx="1">
+            <a:schemeClr val="accent1"/>
+          </a:lnRef>
+          <a:fillRef idx="3">
+            <a:schemeClr val="accent1"/>
+          </a:fillRef>
+          <a:effectRef idx="2">
+            <a:schemeClr val="accent1"/>
+          </a:effectRef>
+          <a:fontRef idx="minor">
+            <a:schemeClr val="lt1"/>
+          </a:fontRef>
+        </p:style>
+        <p:txBody>
+          <a:bodyPr rtlCol="0" anchor="ctr" wrap="square" lIns="109728" rIns="73152" tIns="36576" bIns="36576"/>
+          <a:lstStyle/>
+          <a:p>
+            <a:pPr algn="ctr">
+              <a:defRPr sz="1150" b="1">
+                <a:solidFill>
+                  <a:srgbClr val="1E5E3C"/>
+                </a:solidFill>
+              </a:defRPr>
+            </a:pPr>
+            <a:r>
+              <a:t>✅ Arquivo salesinsight.py + notebook SalesInsight_PY_Colab.ipynb</a:t>
+            </a:r>
+          </a:p>
+        </p:txBody>
+      </p:sp>
+      <p:sp>
+        <p:nvSpPr>
+          <p:cNvPr id="5" name="Rounded Rectangle 4"/>
+          <p:cNvSpPr/>
+          <p:nvPr/>
+        </p:nvSpPr>
+        <p:spPr>
+          <a:xfrm>
+            <a:off x="457200" y="1444752"/>
+            <a:ext cx="5501487" cy="310896"/>
+          </a:xfrm>
+          <a:prstGeom prst="roundRect">
+            <a:avLst/>
+          </a:prstGeom>
+          <a:solidFill>
+            <a:srgbClr val="EAF6EF"/>
+          </a:solidFill>
+          <a:ln w="12700">
+            <a:solidFill>
+              <a:srgbClr val="2E8B57"/>
+            </a:solidFill>
+          </a:ln>
+          <a:effectLst/>
+        </p:spPr>
+        <p:style>
+          <a:lnRef idx="1">
+            <a:schemeClr val="accent1"/>
+          </a:lnRef>
+          <a:fillRef idx="3">
+            <a:schemeClr val="accent1"/>
+          </a:fillRef>
+          <a:effectRef idx="2">
+            <a:schemeClr val="accent1"/>
+          </a:effectRef>
+          <a:fontRef idx="minor">
+            <a:schemeClr val="lt1"/>
+          </a:fontRef>
+        </p:style>
+        <p:txBody>
+          <a:bodyPr rtlCol="0" anchor="ctr" wrap="square" lIns="109728" rIns="73152" tIns="36576" bIns="36576"/>
+          <a:lstStyle/>
+          <a:p>
+            <a:pPr algn="ctr">
+              <a:defRPr sz="1150" b="1">
+                <a:solidFill>
+                  <a:srgbClr val="1E5E3C"/>
+                </a:solidFill>
+              </a:defRPr>
+            </a:pPr>
+            <a:r>
+              <a:t>✅ README.md com objetivo, execução e conceitos aplicados</a:t>
+            </a:r>
+          </a:p>
+        </p:txBody>
+      </p:sp>
+      <p:sp>
+        <p:nvSpPr>
+          <p:cNvPr id="6" name="Rounded Rectangle 5"/>
+          <p:cNvSpPr/>
+          <p:nvPr/>
+        </p:nvSpPr>
+        <p:spPr>
+          <a:xfrm>
+            <a:off x="6233007" y="1444752"/>
+            <a:ext cx="5501487" cy="310896"/>
+          </a:xfrm>
+          <a:prstGeom prst="roundRect">
+            <a:avLst/>
+          </a:prstGeom>
+          <a:solidFill>
+            <a:srgbClr val="EAF6EF"/>
+          </a:solidFill>
+          <a:ln w="12700">
+            <a:solidFill>
+              <a:srgbClr val="2E8B57"/>
+            </a:solidFill>
+          </a:ln>
+          <a:effectLst/>
+        </p:spPr>
+        <p:style>
+          <a:lnRef idx="1">
+            <a:schemeClr val="accent1"/>
+          </a:lnRef>
+          <a:fillRef idx="3">
+            <a:schemeClr val="accent1"/>
+          </a:fillRef>
+          <a:effectRef idx="2">
+            <a:schemeClr val="accent1"/>
+          </a:effectRef>
+          <a:fontRef idx="minor">
+            <a:schemeClr val="lt1"/>
+          </a:fontRef>
+        </p:style>
+        <p:txBody>
+          <a:bodyPr rtlCol="0" anchor="ctr" wrap="square" lIns="109728" rIns="73152" tIns="36576" bIns="36576"/>
+          <a:lstStyle/>
+          <a:p>
+            <a:pPr algn="ctr">
+              <a:defRPr sz="1150" b="1">
+                <a:solidFill>
+                  <a:srgbClr val="1E5E3C"/>
+                </a:solidFill>
+              </a:defRPr>
+            </a:pPr>
+            <a:r>
+              <a:t>✅ vendas.csv gerado pelo próprio código (seed=42, reprodutível)</a:t>
+            </a:r>
+          </a:p>
+        </p:txBody>
+      </p:sp>
+      <p:sp>
+        <p:nvSpPr>
+          <p:cNvPr id="7" name="Rounded Rectangle 6"/>
+          <p:cNvSpPr/>
+          <p:nvPr/>
+        </p:nvSpPr>
+        <p:spPr>
+          <a:xfrm>
+            <a:off x="457200" y="1792224"/>
+            <a:ext cx="5501487" cy="310896"/>
+          </a:xfrm>
+          <a:prstGeom prst="roundRect">
+            <a:avLst/>
+          </a:prstGeom>
+          <a:solidFill>
+            <a:srgbClr val="EAF6EF"/>
+          </a:solidFill>
+          <a:ln w="12700">
+            <a:solidFill>
+              <a:srgbClr val="2E8B57"/>
+            </a:solidFill>
+          </a:ln>
+          <a:effectLst/>
+        </p:spPr>
+        <p:style>
+          <a:lnRef idx="1">
+            <a:schemeClr val="accent1"/>
+          </a:lnRef>
+          <a:fillRef idx="3">
+            <a:schemeClr val="accent1"/>
+          </a:fillRef>
+          <a:effectRef idx="2">
+            <a:schemeClr val="accent1"/>
+          </a:effectRef>
+          <a:fontRef idx="minor">
+            <a:schemeClr val="lt1"/>
+          </a:fontRef>
+        </p:style>
+        <p:txBody>
+          <a:bodyPr rtlCol="0" anchor="ctr" wrap="square" lIns="109728" rIns="73152" tIns="36576" bIns="36576"/>
+          <a:lstStyle/>
+          <a:p>
+            <a:pPr algn="ctr">
+              <a:defRPr sz="1150" b="1">
+                <a:solidFill>
+                  <a:srgbClr val="1E5E3C"/>
+                </a:solidFill>
+              </a:defRPr>
+            </a:pPr>
+            <a:r>
+              <a:t>✅ Inspeção com .shape, .dtypes, .isnull(), .head() (RF02)</a:t>
+            </a:r>
+          </a:p>
+        </p:txBody>
+      </p:sp>
+      <p:sp>
+        <p:nvSpPr>
+          <p:cNvPr id="8" name="Rounded Rectangle 7"/>
+          <p:cNvSpPr/>
+          <p:nvPr/>
+        </p:nvSpPr>
+        <p:spPr>
+          <a:xfrm>
+            <a:off x="6233007" y="1792224"/>
+            <a:ext cx="5501487" cy="310896"/>
+          </a:xfrm>
+          <a:prstGeom prst="roundRect">
+            <a:avLst/>
+          </a:prstGeom>
+          <a:solidFill>
+            <a:srgbClr val="EAF6EF"/>
+          </a:solidFill>
+          <a:ln w="12700">
+            <a:solidFill>
+              <a:srgbClr val="2E8B57"/>
+            </a:solidFill>
+          </a:ln>
+          <a:effectLst/>
+        </p:spPr>
+        <p:style>
+          <a:lnRef idx="1">
+            <a:schemeClr val="accent1"/>
+          </a:lnRef>
+          <a:fillRef idx="3">
+            <a:schemeClr val="accent1"/>
+          </a:fillRef>
+          <a:effectRef idx="2">
+            <a:schemeClr val="accent1"/>
+          </a:effectRef>
+          <a:fontRef idx="minor">
+            <a:schemeClr val="lt1"/>
+          </a:fontRef>
+        </p:style>
+        <p:txBody>
+          <a:bodyPr rtlCol="0" anchor="ctr" wrap="square" lIns="109728" rIns="73152" tIns="36576" bIns="36576"/>
+          <a:lstStyle/>
+          <a:p>
+            <a:pPr algn="ctr">
+              <a:defRPr sz="1150" b="1">
+                <a:solidFill>
+                  <a:srgbClr val="1E5E3C"/>
+                </a:solidFill>
+              </a:defRPr>
+            </a:pPr>
+            <a:r>
+              <a:t>✅ Conversão de tipo e remoção de data inválida + relatório (RF03)</a:t>
+            </a:r>
+          </a:p>
+        </p:txBody>
+      </p:sp>
+      <p:sp>
+        <p:nvSpPr>
+          <p:cNvPr id="9" name="Rounded Rectangle 8"/>
+          <p:cNvSpPr/>
+          <p:nvPr/>
+        </p:nvSpPr>
+        <p:spPr>
+          <a:xfrm>
+            <a:off x="457200" y="2139696"/>
+            <a:ext cx="5501487" cy="310896"/>
+          </a:xfrm>
+          <a:prstGeom prst="roundRect">
+            <a:avLst/>
+          </a:prstGeom>
+          <a:solidFill>
+            <a:srgbClr val="EAF6EF"/>
+          </a:solidFill>
+          <a:ln w="12700">
+            <a:solidFill>
+              <a:srgbClr val="2E8B57"/>
+            </a:solidFill>
+          </a:ln>
+          <a:effectLst/>
+        </p:spPr>
+        <p:style>
+          <a:lnRef idx="1">
+            <a:schemeClr val="accent1"/>
+          </a:lnRef>
+          <a:fillRef idx="3">
+            <a:schemeClr val="accent1"/>
+          </a:fillRef>
+          <a:effectRef idx="2">
+            <a:schemeClr val="accent1"/>
+          </a:effectRef>
+          <a:fontRef idx="minor">
+            <a:schemeClr val="lt1"/>
+          </a:fontRef>
+        </p:style>
+        <p:txBody>
+          <a:bodyPr rtlCol="0" anchor="ctr" wrap="square" lIns="109728" rIns="73152" tIns="36576" bIns="36576"/>
+          <a:lstStyle/>
+          <a:p>
+            <a:pPr algn="ctr">
+              <a:defRPr sz="1150" b="1">
+                <a:solidFill>
+                  <a:srgbClr val="1E5E3C"/>
+                </a:solidFill>
+              </a:defRPr>
+            </a:pPr>
+            <a:r>
+              <a:t>✅ datetime: mês, trimestre e ano extraídos (RF04)</a:t>
+            </a:r>
+          </a:p>
+        </p:txBody>
+      </p:sp>
+      <p:sp>
+        <p:nvSpPr>
+          <p:cNvPr id="10" name="Rounded Rectangle 9"/>
+          <p:cNvSpPr/>
+          <p:nvPr/>
+        </p:nvSpPr>
+        <p:spPr>
+          <a:xfrm>
+            <a:off x="6233007" y="2139696"/>
+            <a:ext cx="5501487" cy="310896"/>
+          </a:xfrm>
+          <a:prstGeom prst="roundRect">
+            <a:avLst/>
+          </a:prstGeom>
+          <a:solidFill>
+            <a:srgbClr val="EAF6EF"/>
+          </a:solidFill>
+          <a:ln w="12700">
+            <a:solidFill>
+              <a:srgbClr val="2E8B57"/>
+            </a:solidFill>
+          </a:ln>
+          <a:effectLst/>
+        </p:spPr>
+        <p:style>
+          <a:lnRef idx="1">
+            <a:schemeClr val="accent1"/>
+          </a:lnRef>
+          <a:fillRef idx="3">
+            <a:schemeClr val="accent1"/>
+          </a:fillRef>
+          <a:effectRef idx="2">
+            <a:schemeClr val="accent1"/>
+          </a:effectRef>
+          <a:fontRef idx="minor">
+            <a:schemeClr val="lt1"/>
+          </a:fontRef>
+        </p:style>
+        <p:txBody>
+          <a:bodyPr rtlCol="0" anchor="ctr" wrap="square" lIns="109728" rIns="73152" tIns="36576" bIns="36576"/>
+          <a:lstStyle/>
+          <a:p>
+            <a:pPr algn="ctr">
+              <a:defRPr sz="1150" b="1">
+                <a:solidFill>
+                  <a:srgbClr val="1E5E3C"/>
+                </a:solidFill>
+              </a:defRPr>
+            </a:pPr>
+            <a:r>
+              <a:t>✅ Colunas derivadas: receita_total, faixa_receita_item (RF04)</a:t>
+            </a:r>
+          </a:p>
+        </p:txBody>
+      </p:sp>
+      <p:sp>
+        <p:nvSpPr>
+          <p:cNvPr id="11" name="Rounded Rectangle 10"/>
+          <p:cNvSpPr/>
+          <p:nvPr/>
+        </p:nvSpPr>
+        <p:spPr>
+          <a:xfrm>
+            <a:off x="457200" y="2487168"/>
+            <a:ext cx="5501487" cy="310896"/>
+          </a:xfrm>
+          <a:prstGeom prst="roundRect">
+            <a:avLst/>
+          </a:prstGeom>
+          <a:solidFill>
+            <a:srgbClr val="EAF6EF"/>
+          </a:solidFill>
+          <a:ln w="12700">
+            <a:solidFill>
+              <a:srgbClr val="2E8B57"/>
+            </a:solidFill>
+          </a:ln>
+          <a:effectLst/>
+        </p:spPr>
+        <p:style>
+          <a:lnRef idx="1">
+            <a:schemeClr val="accent1"/>
+          </a:lnRef>
+          <a:fillRef idx="3">
+            <a:schemeClr val="accent1"/>
+          </a:fillRef>
+          <a:effectRef idx="2">
+            <a:schemeClr val="accent1"/>
+          </a:effectRef>
+          <a:fontRef idx="minor">
+            <a:schemeClr val="lt1"/>
+          </a:fontRef>
+        </p:style>
+        <p:txBody>
+          <a:bodyPr rtlCol="0" anchor="ctr" wrap="square" lIns="109728" rIns="73152" tIns="36576" bIns="36576"/>
+          <a:lstStyle/>
+          <a:p>
+            <a:pPr algn="ctr">
+              <a:defRPr sz="1150" b="1">
+                <a:solidFill>
+                  <a:srgbClr val="1E5E3C"/>
+                </a:solidFill>
+              </a:defRPr>
+            </a:pPr>
+            <a:r>
+              <a:t>✅ Transformação condicional vetorizada com np.select (RF04)</a:t>
+            </a:r>
+          </a:p>
+        </p:txBody>
+      </p:sp>
+      <p:sp>
+        <p:nvSpPr>
+          <p:cNvPr id="12" name="Rounded Rectangle 11"/>
+          <p:cNvSpPr/>
+          <p:nvPr/>
+        </p:nvSpPr>
+        <p:spPr>
+          <a:xfrm>
+            <a:off x="6233007" y="2487168"/>
+            <a:ext cx="5501487" cy="310896"/>
+          </a:xfrm>
+          <a:prstGeom prst="roundRect">
+            <a:avLst/>
+          </a:prstGeom>
+          <a:solidFill>
+            <a:srgbClr val="EAF6EF"/>
+          </a:solidFill>
+          <a:ln w="12700">
+            <a:solidFill>
+              <a:srgbClr val="2E8B57"/>
+            </a:solidFill>
+          </a:ln>
+          <a:effectLst/>
+        </p:spPr>
+        <p:style>
+          <a:lnRef idx="1">
+            <a:schemeClr val="accent1"/>
+          </a:lnRef>
+          <a:fillRef idx="3">
+            <a:schemeClr val="accent1"/>
+          </a:fillRef>
+          <a:effectRef idx="2">
+            <a:schemeClr val="accent1"/>
+          </a:effectRef>
+          <a:fontRef idx="minor">
+            <a:schemeClr val="lt1"/>
+          </a:fontRef>
+        </p:style>
+        <p:txBody>
+          <a:bodyPr rtlCol="0" anchor="ctr" wrap="square" lIns="109728" rIns="73152" tIns="36576" bIns="36576"/>
+          <a:lstStyle/>
+          <a:p>
+            <a:pPr algn="ctr">
+              <a:defRPr sz="1150" b="1">
+                <a:solidFill>
+                  <a:srgbClr val="1E5E3C"/>
+                </a:solidFill>
+              </a:defRPr>
+            </a:pPr>
+            <a:r>
+              <a:t>✅ groupby por mês, produto, categoria e região (RF05)</a:t>
+            </a:r>
+          </a:p>
+        </p:txBody>
+      </p:sp>
+      <p:sp>
+        <p:nvSpPr>
+          <p:cNvPr id="13" name="Rounded Rectangle 12"/>
+          <p:cNvSpPr/>
+          <p:nvPr/>
+        </p:nvSpPr>
+        <p:spPr>
+          <a:xfrm>
+            <a:off x="457200" y="2834640"/>
+            <a:ext cx="5501487" cy="310896"/>
+          </a:xfrm>
+          <a:prstGeom prst="roundRect">
+            <a:avLst/>
+          </a:prstGeom>
+          <a:solidFill>
+            <a:srgbClr val="EAF6EF"/>
+          </a:solidFill>
+          <a:ln w="12700">
+            <a:solidFill>
+              <a:srgbClr val="2E8B57"/>
+            </a:solidFill>
+          </a:ln>
+          <a:effectLst/>
+        </p:spPr>
+        <p:style>
+          <a:lnRef idx="1">
+            <a:schemeClr val="accent1"/>
+          </a:lnRef>
+          <a:fillRef idx="3">
+            <a:schemeClr val="accent1"/>
+          </a:fillRef>
+          <a:effectRef idx="2">
+            <a:schemeClr val="accent1"/>
+          </a:effectRef>
+          <a:fontRef idx="minor">
+            <a:schemeClr val="lt1"/>
+          </a:fontRef>
+        </p:style>
+        <p:txBody>
+          <a:bodyPr rtlCol="0" anchor="ctr" wrap="square" lIns="109728" rIns="73152" tIns="36576" bIns="36576"/>
+          <a:lstStyle/>
+          <a:p>
+            <a:pPr algn="ctr">
+              <a:defRPr sz="1150" b="1">
+                <a:solidFill>
+                  <a:srgbClr val="1E5E3C"/>
+                </a:solidFill>
+              </a:defRPr>
+            </a:pPr>
+            <a:r>
+              <a:t>✅ Segmentação Bronze/Prata/Ouro com função lambda (RF06)</a:t>
+            </a:r>
+          </a:p>
+        </p:txBody>
+      </p:sp>
+      <p:sp>
+        <p:nvSpPr>
+          <p:cNvPr id="14" name="Rounded Rectangle 13"/>
+          <p:cNvSpPr/>
+          <p:nvPr/>
+        </p:nvSpPr>
+        <p:spPr>
+          <a:xfrm>
+            <a:off x="6233007" y="2834640"/>
+            <a:ext cx="5501487" cy="310896"/>
+          </a:xfrm>
+          <a:prstGeom prst="roundRect">
+            <a:avLst/>
+          </a:prstGeom>
+          <a:solidFill>
+            <a:srgbClr val="EAF6EF"/>
+          </a:solidFill>
+          <a:ln w="12700">
+            <a:solidFill>
+              <a:srgbClr val="2E8B57"/>
+            </a:solidFill>
+          </a:ln>
+          <a:effectLst/>
+        </p:spPr>
+        <p:style>
+          <a:lnRef idx="1">
+            <a:schemeClr val="accent1"/>
+          </a:lnRef>
+          <a:fillRef idx="3">
+            <a:schemeClr val="accent1"/>
+          </a:fillRef>
+          <a:effectRef idx="2">
+            <a:schemeClr val="accent1"/>
+          </a:effectRef>
+          <a:fontRef idx="minor">
+            <a:schemeClr val="lt1"/>
+          </a:fontRef>
+        </p:style>
+        <p:txBody>
+          <a:bodyPr rtlCol="0" anchor="ctr" wrap="square" lIns="109728" rIns="73152" tIns="36576" bIns="36576"/>
+          <a:lstStyle/>
+          <a:p>
+            <a:pPr algn="ctr">
+              <a:defRPr sz="1150" b="1">
+                <a:solidFill>
+                  <a:srgbClr val="1E5E3C"/>
+                </a:solidFill>
+              </a:defRPr>
+            </a:pPr>
+            <a:r>
+              <a:t>✅ Gráfico de linha — receita por mês (RF07)</a:t>
+            </a:r>
+          </a:p>
+        </p:txBody>
+      </p:sp>
+      <p:sp>
+        <p:nvSpPr>
+          <p:cNvPr id="15" name="Rounded Rectangle 14"/>
+          <p:cNvSpPr/>
+          <p:nvPr/>
+        </p:nvSpPr>
+        <p:spPr>
+          <a:xfrm>
+            <a:off x="457200" y="3182112"/>
+            <a:ext cx="5501487" cy="310896"/>
+          </a:xfrm>
+          <a:prstGeom prst="roundRect">
+            <a:avLst/>
+          </a:prstGeom>
+          <a:solidFill>
+            <a:srgbClr val="EAF6EF"/>
+          </a:solidFill>
+          <a:ln w="12700">
+            <a:solidFill>
+              <a:srgbClr val="2E8B57"/>
+            </a:solidFill>
+          </a:ln>
+          <a:effectLst/>
+        </p:spPr>
+        <p:style>
+          <a:lnRef idx="1">
+            <a:schemeClr val="accent1"/>
+          </a:lnRef>
+          <a:fillRef idx="3">
+            <a:schemeClr val="accent1"/>
+          </a:fillRef>
+          <a:effectRef idx="2">
+            <a:schemeClr val="accent1"/>
+          </a:effectRef>
+          <a:fontRef idx="minor">
+            <a:schemeClr val="lt1"/>
+          </a:fontRef>
+        </p:style>
+        <p:txBody>
+          <a:bodyPr rtlCol="0" anchor="ctr" wrap="square" lIns="109728" rIns="73152" tIns="36576" bIns="36576"/>
+          <a:lstStyle/>
+          <a:p>
+            <a:pPr algn="ctr">
+              <a:defRPr sz="1150" b="1">
+                <a:solidFill>
+                  <a:srgbClr val="1E5E3C"/>
+                </a:solidFill>
+              </a:defRPr>
+            </a:pPr>
+            <a:r>
+              <a:t>✅ Gráfico de barras — top produtos (RF07)</a:t>
+            </a:r>
+          </a:p>
+        </p:txBody>
+      </p:sp>
+      <p:sp>
+        <p:nvSpPr>
+          <p:cNvPr id="16" name="Rounded Rectangle 15"/>
+          <p:cNvSpPr/>
+          <p:nvPr/>
+        </p:nvSpPr>
+        <p:spPr>
+          <a:xfrm>
+            <a:off x="6233007" y="3182112"/>
+            <a:ext cx="5501487" cy="310896"/>
+          </a:xfrm>
+          <a:prstGeom prst="roundRect">
+            <a:avLst/>
+          </a:prstGeom>
+          <a:solidFill>
+            <a:srgbClr val="EAF6EF"/>
+          </a:solidFill>
+          <a:ln w="12700">
+            <a:solidFill>
+              <a:srgbClr val="2E8B57"/>
+            </a:solidFill>
+          </a:ln>
+          <a:effectLst/>
+        </p:spPr>
+        <p:style>
+          <a:lnRef idx="1">
+            <a:schemeClr val="accent1"/>
+          </a:lnRef>
+          <a:fillRef idx="3">
+            <a:schemeClr val="accent1"/>
+          </a:fillRef>
+          <a:effectRef idx="2">
+            <a:schemeClr val="accent1"/>
+          </a:effectRef>
+          <a:fontRef idx="minor">
+            <a:schemeClr val="lt1"/>
+          </a:fontRef>
+        </p:style>
+        <p:txBody>
+          <a:bodyPr rtlCol="0" anchor="ctr" wrap="square" lIns="109728" rIns="73152" tIns="36576" bIns="36576"/>
+          <a:lstStyle/>
+          <a:p>
+            <a:pPr algn="ctr">
+              <a:defRPr sz="1150" b="1">
+                <a:solidFill>
+                  <a:srgbClr val="1E5E3C"/>
+                </a:solidFill>
+              </a:defRPr>
+            </a:pPr>
+            <a:r>
+              <a:t>✅ Gráfico de dispersão — quantidade × receita (RF07)</a:t>
+            </a:r>
+          </a:p>
+        </p:txBody>
+      </p:sp>
+      <p:sp>
+        <p:nvSpPr>
+          <p:cNvPr id="17" name="Rounded Rectangle 16"/>
+          <p:cNvSpPr/>
+          <p:nvPr/>
+        </p:nvSpPr>
+        <p:spPr>
+          <a:xfrm>
+            <a:off x="457200" y="3529584"/>
+            <a:ext cx="5501487" cy="310896"/>
+          </a:xfrm>
+          <a:prstGeom prst="roundRect">
+            <a:avLst/>
+          </a:prstGeom>
+          <a:solidFill>
+            <a:srgbClr val="EAF6EF"/>
+          </a:solidFill>
+          <a:ln w="12700">
+            <a:solidFill>
+              <a:srgbClr val="2E8B57"/>
+            </a:solidFill>
+          </a:ln>
+          <a:effectLst/>
+        </p:spPr>
+        <p:style>
+          <a:lnRef idx="1">
+            <a:schemeClr val="accent1"/>
+          </a:lnRef>
+          <a:fillRef idx="3">
+            <a:schemeClr val="accent1"/>
+          </a:fillRef>
+          <a:effectRef idx="2">
+            <a:schemeClr val="accent1"/>
+          </a:effectRef>
+          <a:fontRef idx="minor">
+            <a:schemeClr val="lt1"/>
+          </a:fontRef>
+        </p:style>
+        <p:txBody>
+          <a:bodyPr rtlCol="0" anchor="ctr" wrap="square" lIns="109728" rIns="73152" tIns="36576" bIns="36576"/>
+          <a:lstStyle/>
+          <a:p>
+            <a:pPr algn="ctr">
+              <a:defRPr sz="1150" b="1">
+                <a:solidFill>
+                  <a:srgbClr val="1E5E3C"/>
+                </a:solidFill>
+              </a:defRPr>
+            </a:pPr>
+            <a:r>
+              <a:t>✅ Painel com subplots 2×2 e fig.suptitle() (RF07)</a:t>
+            </a:r>
+          </a:p>
+        </p:txBody>
+      </p:sp>
+      <p:sp>
+        <p:nvSpPr>
+          <p:cNvPr id="18" name="Rounded Rectangle 17"/>
+          <p:cNvSpPr/>
+          <p:nvPr/>
+        </p:nvSpPr>
+        <p:spPr>
+          <a:xfrm>
+            <a:off x="6233007" y="3529584"/>
+            <a:ext cx="5501487" cy="310896"/>
+          </a:xfrm>
+          <a:prstGeom prst="roundRect">
+            <a:avLst/>
+          </a:prstGeom>
+          <a:solidFill>
+            <a:srgbClr val="EAF6EF"/>
+          </a:solidFill>
+          <a:ln w="12700">
+            <a:solidFill>
+              <a:srgbClr val="2E8B57"/>
+            </a:solidFill>
+          </a:ln>
+          <a:effectLst/>
+        </p:spPr>
+        <p:style>
+          <a:lnRef idx="1">
+            <a:schemeClr val="accent1"/>
+          </a:lnRef>
+          <a:fillRef idx="3">
+            <a:schemeClr val="accent1"/>
+          </a:fillRef>
+          <a:effectRef idx="2">
+            <a:schemeClr val="accent1"/>
+          </a:effectRef>
+          <a:fontRef idx="minor">
+            <a:schemeClr val="lt1"/>
+          </a:fontRef>
+        </p:style>
+        <p:txBody>
+          <a:bodyPr rtlCol="0" anchor="ctr" wrap="square" lIns="109728" rIns="73152" tIns="36576" bIns="36576"/>
+          <a:lstStyle/>
+          <a:p>
+            <a:pPr algn="ctr">
+              <a:defRPr sz="1150" b="1">
+                <a:solidFill>
+                  <a:srgbClr val="1E5E3C"/>
+                </a:solidFill>
+              </a:defRPr>
+            </a:pPr>
+            <a:r>
+              <a:t>✅ Todas as figuras customizadas e exportadas em PNG, dpi≥100 (RF07)</a:t>
+            </a:r>
+          </a:p>
+        </p:txBody>
+      </p:sp>
+      <p:sp>
+        <p:nvSpPr>
+          <p:cNvPr id="19" name="Rounded Rectangle 18"/>
+          <p:cNvSpPr/>
+          <p:nvPr/>
+        </p:nvSpPr>
+        <p:spPr>
+          <a:xfrm>
+            <a:off x="457200" y="3877056"/>
+            <a:ext cx="5501487" cy="310896"/>
+          </a:xfrm>
+          <a:prstGeom prst="roundRect">
+            <a:avLst/>
+          </a:prstGeom>
+          <a:solidFill>
+            <a:srgbClr val="EAF6EF"/>
+          </a:solidFill>
+          <a:ln w="12700">
+            <a:solidFill>
+              <a:srgbClr val="2E8B57"/>
+            </a:solidFill>
+          </a:ln>
+          <a:effectLst/>
+        </p:spPr>
+        <p:style>
+          <a:lnRef idx="1">
+            <a:schemeClr val="accent1"/>
+          </a:lnRef>
+          <a:fillRef idx="3">
+            <a:schemeClr val="accent1"/>
+          </a:fillRef>
+          <a:effectRef idx="2">
+            <a:schemeClr val="accent1"/>
+          </a:effectRef>
+          <a:fontRef idx="minor">
+            <a:schemeClr val="lt1"/>
+          </a:fontRef>
+        </p:style>
+        <p:txBody>
+          <a:bodyPr rtlCol="0" anchor="ctr" wrap="square" lIns="109728" rIns="73152" tIns="36576" bIns="36576"/>
+          <a:lstStyle/>
+          <a:p>
+            <a:pPr algn="ctr">
+              <a:defRPr sz="1150" b="1">
+                <a:solidFill>
+                  <a:srgbClr val="1E5E3C"/>
+                </a:solidFill>
+              </a:defRPr>
+            </a:pPr>
+            <a:r>
+              <a:t>✅ Funções com parâmetros, retorno e docstring (RF08)</a:t>
+            </a:r>
+          </a:p>
+        </p:txBody>
+      </p:sp>
+      <p:sp>
+        <p:nvSpPr>
+          <p:cNvPr id="20" name="Rounded Rectangle 19"/>
+          <p:cNvSpPr/>
+          <p:nvPr/>
+        </p:nvSpPr>
+        <p:spPr>
+          <a:xfrm>
+            <a:off x="6233007" y="3877056"/>
+            <a:ext cx="5501487" cy="310896"/>
+          </a:xfrm>
+          <a:prstGeom prst="roundRect">
+            <a:avLst/>
+          </a:prstGeom>
+          <a:solidFill>
+            <a:srgbClr val="EAF6EF"/>
+          </a:solidFill>
+          <a:ln w="12700">
+            <a:solidFill>
+              <a:srgbClr val="2E8B57"/>
+            </a:solidFill>
+          </a:ln>
+          <a:effectLst/>
+        </p:spPr>
+        <p:style>
+          <a:lnRef idx="1">
+            <a:schemeClr val="accent1"/>
+          </a:lnRef>
+          <a:fillRef idx="3">
+            <a:schemeClr val="accent1"/>
+          </a:fillRef>
+          <a:effectRef idx="2">
+            <a:schemeClr val="accent1"/>
+          </a:effectRef>
+          <a:fontRef idx="minor">
+            <a:schemeClr val="lt1"/>
+          </a:fontRef>
+        </p:style>
+        <p:txBody>
+          <a:bodyPr rtlCol="0" anchor="ctr" wrap="square" lIns="109728" rIns="73152" tIns="36576" bIns="36576"/>
+          <a:lstStyle/>
+          <a:p>
+            <a:pPr algn="ctr">
+              <a:defRPr sz="1150" b="1">
+                <a:solidFill>
+                  <a:srgbClr val="1E5E3C"/>
+                </a:solidFill>
+              </a:defRPr>
+            </a:pPr>
+            <a:r>
+              <a:t>✅ Função lambda em pelo menos 2 contextos distintos (RF08)</a:t>
+            </a:r>
+          </a:p>
+        </p:txBody>
+      </p:sp>
+      <p:sp>
+        <p:nvSpPr>
+          <p:cNvPr id="21" name="Rounded Rectangle 20"/>
+          <p:cNvSpPr/>
+          <p:nvPr/>
+        </p:nvSpPr>
+        <p:spPr>
+          <a:xfrm>
+            <a:off x="457200" y="4224528"/>
+            <a:ext cx="5501487" cy="310896"/>
+          </a:xfrm>
+          <a:prstGeom prst="roundRect">
+            <a:avLst/>
+          </a:prstGeom>
+          <a:solidFill>
+            <a:srgbClr val="EAF6EF"/>
+          </a:solidFill>
+          <a:ln w="12700">
+            <a:solidFill>
+              <a:srgbClr val="2E8B57"/>
+            </a:solidFill>
+          </a:ln>
+          <a:effectLst/>
+        </p:spPr>
+        <p:style>
+          <a:lnRef idx="1">
+            <a:schemeClr val="accent1"/>
+          </a:lnRef>
+          <a:fillRef idx="3">
+            <a:schemeClr val="accent1"/>
+          </a:fillRef>
+          <a:effectRef idx="2">
+            <a:schemeClr val="accent1"/>
+          </a:effectRef>
+          <a:fontRef idx="minor">
+            <a:schemeClr val="lt1"/>
+          </a:fontRef>
+        </p:style>
+        <p:txBody>
+          <a:bodyPr rtlCol="0" anchor="ctr" wrap="square" lIns="109728" rIns="73152" tIns="36576" bIns="36576"/>
+          <a:lstStyle/>
+          <a:p>
+            <a:pPr algn="ctr">
+              <a:defRPr sz="1150" b="1">
+                <a:solidFill>
+                  <a:srgbClr val="1E5E3C"/>
+                </a:solidFill>
+              </a:defRPr>
+            </a:pPr>
+            <a:r>
+              <a:t>✅ Função que recebe outra função como argumento (RF08)</a:t>
+            </a:r>
+          </a:p>
+        </p:txBody>
+      </p:sp>
+      <p:sp>
+        <p:nvSpPr>
+          <p:cNvPr id="22" name="Rounded Rectangle 21"/>
+          <p:cNvSpPr/>
+          <p:nvPr/>
+        </p:nvSpPr>
+        <p:spPr>
+          <a:xfrm>
+            <a:off x="6233007" y="4224528"/>
+            <a:ext cx="5501487" cy="310896"/>
+          </a:xfrm>
+          <a:prstGeom prst="roundRect">
+            <a:avLst/>
+          </a:prstGeom>
+          <a:solidFill>
+            <a:srgbClr val="EAF6EF"/>
+          </a:solidFill>
+          <a:ln w="12700">
+            <a:solidFill>
+              <a:srgbClr val="2E8B57"/>
+            </a:solidFill>
+          </a:ln>
+          <a:effectLst/>
+        </p:spPr>
+        <p:style>
+          <a:lnRef idx="1">
+            <a:schemeClr val="accent1"/>
+          </a:lnRef>
+          <a:fillRef idx="3">
+            <a:schemeClr val="accent1"/>
+          </a:fillRef>
+          <a:effectRef idx="2">
+            <a:schemeClr val="accent1"/>
+          </a:effectRef>
+          <a:fontRef idx="minor">
+            <a:schemeClr val="lt1"/>
+          </a:fontRef>
+        </p:style>
+        <p:txBody>
+          <a:bodyPr rtlCol="0" anchor="ctr" wrap="square" lIns="109728" rIns="73152" tIns="36576" bIns="36576"/>
+          <a:lstStyle/>
+          <a:p>
+            <a:pPr algn="ctr">
+              <a:defRPr sz="1150" b="1">
+                <a:solidFill>
+                  <a:srgbClr val="1E5E3C"/>
+                </a:solidFill>
+              </a:defRPr>
+            </a:pPr>
+            <a:r>
+              <a:t>✅ Exportação em CSV e JSON + releitura do JSON (RF09)</a:t>
+            </a:r>
+          </a:p>
+        </p:txBody>
+      </p:sp>
+      <p:sp>
+        <p:nvSpPr>
+          <p:cNvPr id="23" name="Rounded Rectangle 22"/>
+          <p:cNvSpPr/>
+          <p:nvPr/>
+        </p:nvSpPr>
+        <p:spPr>
+          <a:xfrm>
+            <a:off x="457200" y="4572000"/>
+            <a:ext cx="5501487" cy="310896"/>
+          </a:xfrm>
+          <a:prstGeom prst="roundRect">
+            <a:avLst/>
+          </a:prstGeom>
+          <a:solidFill>
+            <a:srgbClr val="EAF6EF"/>
+          </a:solidFill>
+          <a:ln w="12700">
+            <a:solidFill>
+              <a:srgbClr val="2E8B57"/>
+            </a:solidFill>
+          </a:ln>
+          <a:effectLst/>
+        </p:spPr>
+        <p:style>
+          <a:lnRef idx="1">
+            <a:schemeClr val="accent1"/>
+          </a:lnRef>
+          <a:fillRef idx="3">
+            <a:schemeClr val="accent1"/>
+          </a:fillRef>
+          <a:effectRef idx="2">
+            <a:schemeClr val="accent1"/>
+          </a:effectRef>
+          <a:fontRef idx="minor">
+            <a:schemeClr val="lt1"/>
+          </a:fontRef>
+        </p:style>
+        <p:txBody>
+          <a:bodyPr rtlCol="0" anchor="ctr" wrap="square" lIns="109728" rIns="73152" tIns="36576" bIns="36576"/>
+          <a:lstStyle/>
+          <a:p>
+            <a:pPr algn="ctr">
+              <a:defRPr sz="1150" b="1">
+                <a:solidFill>
+                  <a:srgbClr val="1E5E3C"/>
+                </a:solidFill>
+              </a:defRPr>
+            </a:pPr>
+            <a:r>
+              <a:t>✅ Classe AnalisadorDeVendas + main() + if __name__ (RF10)</a:t>
+            </a:r>
+          </a:p>
+        </p:txBody>
+      </p:sp>
+      <p:sp>
+        <p:nvSpPr>
+          <p:cNvPr id="24" name="Rounded Rectangle 23"/>
+          <p:cNvSpPr/>
+          <p:nvPr/>
+        </p:nvSpPr>
+        <p:spPr>
+          <a:xfrm>
+            <a:off x="6233007" y="4572000"/>
+            <a:ext cx="5501487" cy="310896"/>
+          </a:xfrm>
+          <a:prstGeom prst="roundRect">
+            <a:avLst/>
+          </a:prstGeom>
+          <a:solidFill>
+            <a:srgbClr val="EAF6EF"/>
+          </a:solidFill>
+          <a:ln w="12700">
+            <a:solidFill>
+              <a:srgbClr val="2E8B57"/>
+            </a:solidFill>
+          </a:ln>
+          <a:effectLst/>
+        </p:spPr>
+        <p:style>
+          <a:lnRef idx="1">
+            <a:schemeClr val="accent1"/>
+          </a:lnRef>
+          <a:fillRef idx="3">
+            <a:schemeClr val="accent1"/>
+          </a:fillRef>
+          <a:effectRef idx="2">
+            <a:schemeClr val="accent1"/>
+          </a:effectRef>
+          <a:fontRef idx="minor">
+            <a:schemeClr val="lt1"/>
+          </a:fontRef>
+        </p:style>
+        <p:txBody>
+          <a:bodyPr rtlCol="0" anchor="ctr" wrap="square" lIns="109728" rIns="73152" tIns="36576" bIns="36576"/>
+          <a:lstStyle/>
+          <a:p>
+            <a:pPr algn="ctr">
+              <a:defRPr sz="1150" b="1">
+                <a:solidFill>
+                  <a:srgbClr val="1E5E3C"/>
+                </a:solidFill>
+              </a:defRPr>
+            </a:pPr>
+            <a:r>
+              <a:t>✅ Fluxo executado do zero sem erros (testado via nbconvert)</a:t>
+            </a:r>
+          </a:p>
+        </p:txBody>
+      </p:sp>
+      <p:sp>
+        <p:nvSpPr>
+          <p:cNvPr id="25" name="Rounded Rectangle 24"/>
+          <p:cNvSpPr/>
+          <p:nvPr/>
+        </p:nvSpPr>
+        <p:spPr>
+          <a:xfrm>
+            <a:off x="457200" y="4919472"/>
+            <a:ext cx="5501487" cy="310896"/>
+          </a:xfrm>
+          <a:prstGeom prst="roundRect">
+            <a:avLst/>
+          </a:prstGeom>
+          <a:solidFill>
+            <a:srgbClr val="EAF6EF"/>
+          </a:solidFill>
+          <a:ln w="12700">
+            <a:solidFill>
+              <a:srgbClr val="2E8B57"/>
+            </a:solidFill>
+          </a:ln>
+          <a:effectLst/>
+        </p:spPr>
+        <p:style>
+          <a:lnRef idx="1">
+            <a:schemeClr val="accent1"/>
+          </a:lnRef>
+          <a:fillRef idx="3">
+            <a:schemeClr val="accent1"/>
+          </a:fillRef>
+          <a:effectRef idx="2">
+            <a:schemeClr val="accent1"/>
+          </a:effectRef>
+          <a:fontRef idx="minor">
+            <a:schemeClr val="lt1"/>
+          </a:fontRef>
+        </p:style>
+        <p:txBody>
+          <a:bodyPr rtlCol="0" anchor="ctr" wrap="square" lIns="109728" rIns="73152" tIns="36576" bIns="36576"/>
+          <a:lstStyle/>
+          <a:p>
+            <a:pPr algn="ctr">
+              <a:defRPr sz="1150" b="1">
+                <a:solidFill>
+                  <a:srgbClr val="1E5E3C"/>
+                </a:solidFill>
+              </a:defRPr>
+            </a:pPr>
+            <a:r>
+              <a:t>✅ Branches descritivas: main, develop, feat/pipeline-dados, docs/readme</a:t>
+            </a:r>
+          </a:p>
+        </p:txBody>
+      </p:sp>
+      <p:sp>
+        <p:nvSpPr>
+          <p:cNvPr id="26" name="Rounded Rectangle 25"/>
+          <p:cNvSpPr/>
+          <p:nvPr/>
+        </p:nvSpPr>
+        <p:spPr>
+          <a:xfrm>
+            <a:off x="6233007" y="4919472"/>
+            <a:ext cx="5501487" cy="310896"/>
+          </a:xfrm>
+          <a:prstGeom prst="roundRect">
+            <a:avLst/>
+          </a:prstGeom>
+          <a:solidFill>
+            <a:srgbClr val="EAF6EF"/>
+          </a:solidFill>
+          <a:ln w="12700">
+            <a:solidFill>
+              <a:srgbClr val="2E8B57"/>
+            </a:solidFill>
+          </a:ln>
+          <a:effectLst/>
+        </p:spPr>
+        <p:style>
+          <a:lnRef idx="1">
+            <a:schemeClr val="accent1"/>
+          </a:lnRef>
+          <a:fillRef idx="3">
+            <a:schemeClr val="accent1"/>
+          </a:fillRef>
+          <a:effectRef idx="2">
+            <a:schemeClr val="accent1"/>
+          </a:effectRef>
+          <a:fontRef idx="minor">
+            <a:schemeClr val="lt1"/>
+          </a:fontRef>
+        </p:style>
+        <p:txBody>
+          <a:bodyPr rtlCol="0" anchor="ctr" wrap="square" lIns="109728" rIns="73152" tIns="36576" bIns="36576"/>
+          <a:lstStyle/>
+          <a:p>
+            <a:pPr algn="ctr">
+              <a:defRPr sz="1150" b="1">
+                <a:solidFill>
+                  <a:srgbClr val="1E5E3C"/>
+                </a:solidFill>
+              </a:defRPr>
+            </a:pPr>
+            <a:r>
+              <a:t>✅ Commits no padrão conventional commits</a:t>
+            </a:r>
+          </a:p>
+        </p:txBody>
+      </p:sp>
+      <p:sp>
+        <p:nvSpPr>
+          <p:cNvPr id="27" name="Rounded Rectangle 26"/>
+          <p:cNvSpPr/>
+          <p:nvPr/>
+        </p:nvSpPr>
+        <p:spPr>
+          <a:xfrm>
+            <a:off x="457200" y="5266944"/>
+            <a:ext cx="5501487" cy="310896"/>
+          </a:xfrm>
+          <a:prstGeom prst="roundRect">
+            <a:avLst/>
+          </a:prstGeom>
+          <a:solidFill>
+            <a:srgbClr val="EAF6EF"/>
+          </a:solidFill>
+          <a:ln w="12700">
+            <a:solidFill>
+              <a:srgbClr val="2E8B57"/>
+            </a:solidFill>
+          </a:ln>
+          <a:effectLst/>
+        </p:spPr>
+        <p:style>
+          <a:lnRef idx="1">
+            <a:schemeClr val="accent1"/>
+          </a:lnRef>
+          <a:fillRef idx="3">
+            <a:schemeClr val="accent1"/>
+          </a:fillRef>
+          <a:effectRef idx="2">
+            <a:schemeClr val="accent1"/>
+          </a:effectRef>
+          <a:fontRef idx="minor">
+            <a:schemeClr val="lt1"/>
+          </a:fontRef>
+        </p:style>
+        <p:txBody>
+          <a:bodyPr rtlCol="0" anchor="ctr" wrap="square" lIns="109728" rIns="73152" tIns="36576" bIns="36576"/>
+          <a:lstStyle/>
+          <a:p>
+            <a:pPr algn="ctr">
+              <a:defRPr sz="1150" b="1">
+                <a:solidFill>
+                  <a:srgbClr val="1E5E3C"/>
+                </a:solidFill>
+              </a:defRPr>
+            </a:pPr>
+            <a:r>
+              <a:t>✅ Kanban organizado (Trello, 4 colunas, link público)</a:t>
+            </a:r>
+          </a:p>
+        </p:txBody>
+      </p:sp>
+      <p:sp>
+        <p:nvSpPr>
+          <p:cNvPr id="28" name="Rounded Rectangle 27"/>
+          <p:cNvSpPr/>
+          <p:nvPr/>
+        </p:nvSpPr>
+        <p:spPr>
+          <a:xfrm>
+            <a:off x="6233007" y="5266944"/>
+            <a:ext cx="5501487" cy="310896"/>
+          </a:xfrm>
+          <a:prstGeom prst="roundRect">
+            <a:avLst/>
+          </a:prstGeom>
+          <a:solidFill>
+            <a:srgbClr val="EAF6EF"/>
+          </a:solidFill>
+          <a:ln w="12700">
+            <a:solidFill>
+              <a:srgbClr val="2E8B57"/>
+            </a:solidFill>
+          </a:ln>
+          <a:effectLst/>
+        </p:spPr>
+        <p:style>
+          <a:lnRef idx="1">
+            <a:schemeClr val="accent1"/>
+          </a:lnRef>
+          <a:fillRef idx="3">
+            <a:schemeClr val="accent1"/>
+          </a:fillRef>
+          <a:effectRef idx="2">
+            <a:schemeClr val="accent1"/>
+          </a:effectRef>
+          <a:fontRef idx="minor">
+            <a:schemeClr val="lt1"/>
+          </a:fontRef>
+        </p:style>
+        <p:txBody>
+          <a:bodyPr rtlCol="0" anchor="ctr" wrap="square" lIns="109728" rIns="73152" tIns="36576" bIns="36576"/>
+          <a:lstStyle/>
+          <a:p>
+            <a:pPr algn="ctr">
+              <a:defRPr sz="1150" b="1">
+                <a:solidFill>
+                  <a:srgbClr val="1E5E3C"/>
+                </a:solidFill>
+              </a:defRPr>
+            </a:pPr>
+            <a:r>
+              <a:t>✅ .gitignore configurado e documentado no README</a:t>
+            </a:r>
+          </a:p>
+        </p:txBody>
+      </p:sp>
+      <p:sp>
+        <p:nvSpPr>
+          <p:cNvPr id="29" name="Rounded Rectangle 28"/>
+          <p:cNvSpPr/>
+          <p:nvPr/>
+        </p:nvSpPr>
+        <p:spPr>
+          <a:xfrm>
+            <a:off x="457200" y="5614416"/>
+            <a:ext cx="5501487" cy="310896"/>
+          </a:xfrm>
+          <a:prstGeom prst="roundRect">
+            <a:avLst/>
+          </a:prstGeom>
+          <a:solidFill>
+            <a:srgbClr val="FDF2E3"/>
+          </a:solidFill>
+          <a:ln w="12700">
+            <a:solidFill>
+              <a:srgbClr val="E07B00"/>
+            </a:solidFill>
+          </a:ln>
+          <a:effectLst/>
+        </p:spPr>
+        <p:style>
+          <a:lnRef idx="1">
+            <a:schemeClr val="accent1"/>
+          </a:lnRef>
+          <a:fillRef idx="3">
+            <a:schemeClr val="accent1"/>
+          </a:fillRef>
+          <a:effectRef idx="2">
+            <a:schemeClr val="accent1"/>
+          </a:effectRef>
+          <a:fontRef idx="minor">
+            <a:schemeClr val="lt1"/>
+          </a:fontRef>
+        </p:style>
+        <p:txBody>
+          <a:bodyPr rtlCol="0" anchor="ctr" wrap="square" lIns="109728" rIns="73152" tIns="36576" bIns="36576"/>
+          <a:lstStyle/>
+          <a:p>
+            <a:pPr algn="ctr">
+              <a:defRPr sz="1150" b="0">
+                <a:solidFill>
+                  <a:srgbClr val="E07B00"/>
+                </a:solidFill>
+              </a:defRPr>
+            </a:pPr>
+            <a:r>
+              <a:t>⏳ Vídeo de até 5 min, rosto visível, voz clara</a:t>
+            </a:r>
+          </a:p>
+        </p:txBody>
+      </p:sp>
+      <p:sp>
+        <p:nvSpPr>
+          <p:cNvPr id="30" name="Rounded Rectangle 29"/>
+          <p:cNvSpPr/>
+          <p:nvPr/>
+        </p:nvSpPr>
+        <p:spPr>
+          <a:xfrm>
+            <a:off x="6233007" y="5614416"/>
+            <a:ext cx="5501487" cy="310896"/>
+          </a:xfrm>
+          <a:prstGeom prst="roundRect">
+            <a:avLst/>
+          </a:prstGeom>
+          <a:solidFill>
+            <a:srgbClr val="FDF2E3"/>
+          </a:solidFill>
+          <a:ln w="12700">
+            <a:solidFill>
+              <a:srgbClr val="E07B00"/>
+            </a:solidFill>
+          </a:ln>
+          <a:effectLst/>
+        </p:spPr>
+        <p:style>
+          <a:lnRef idx="1">
+            <a:schemeClr val="accent1"/>
+          </a:lnRef>
+          <a:fillRef idx="3">
+            <a:schemeClr val="accent1"/>
+          </a:fillRef>
+          <a:effectRef idx="2">
+            <a:schemeClr val="accent1"/>
+          </a:effectRef>
+          <a:fontRef idx="minor">
+            <a:schemeClr val="lt1"/>
+          </a:fontRef>
+        </p:style>
+        <p:txBody>
+          <a:bodyPr rtlCol="0" anchor="ctr" wrap="square" lIns="109728" rIns="73152" tIns="36576" bIns="36576"/>
+          <a:lstStyle/>
+          <a:p>
+            <a:pPr algn="ctr">
+              <a:defRPr sz="1150" b="0">
+                <a:solidFill>
+                  <a:srgbClr val="E07B00"/>
+                </a:solidFill>
+              </a:defRPr>
+            </a:pPr>
+            <a:r>
+              <a:t>⏳ Link do vídeo inserido no README.md</a:t>
+            </a:r>
+          </a:p>
+        </p:txBody>
+      </p:sp>
+      <p:sp>
+        <p:nvSpPr>
+          <p:cNvPr id="31" name="Rounded Rectangle 30"/>
+          <p:cNvSpPr/>
+          <p:nvPr/>
+        </p:nvSpPr>
+        <p:spPr>
+          <a:xfrm>
+            <a:off x="457200" y="5961888"/>
+            <a:ext cx="5501487" cy="310896"/>
+          </a:xfrm>
+          <a:prstGeom prst="roundRect">
+            <a:avLst/>
+          </a:prstGeom>
+          <a:solidFill>
+            <a:srgbClr val="FDF2E3"/>
+          </a:solidFill>
+          <a:ln w="12700">
+            <a:solidFill>
+              <a:srgbClr val="E07B00"/>
+            </a:solidFill>
+          </a:ln>
+          <a:effectLst/>
+        </p:spPr>
+        <p:style>
+          <a:lnRef idx="1">
+            <a:schemeClr val="accent1"/>
+          </a:lnRef>
+          <a:fillRef idx="3">
+            <a:schemeClr val="accent1"/>
+          </a:fillRef>
+          <a:effectRef idx="2">
+            <a:schemeClr val="accent1"/>
+          </a:effectRef>
+          <a:fontRef idx="minor">
+            <a:schemeClr val="lt1"/>
+          </a:fontRef>
+        </p:style>
+        <p:txBody>
+          <a:bodyPr rtlCol="0" anchor="ctr" wrap="square" lIns="109728" rIns="73152" tIns="36576" bIns="36576"/>
+          <a:lstStyle/>
+          <a:p>
+            <a:pPr algn="ctr">
+              <a:defRPr sz="1150" b="0">
+                <a:solidFill>
+                  <a:srgbClr val="E07B00"/>
+                </a:solidFill>
+              </a:defRPr>
+            </a:pPr>
+            <a:r>
+              <a:t>⏳ Links (GitHub + vídeo + Kanban) enviados no AVA</a:t>
+            </a:r>
+          </a:p>
+        </p:txBody>
+      </p:sp>
+      <p:sp>
+        <p:nvSpPr>
+          <p:cNvPr id="32" name="TextBox 31"/>
+          <p:cNvSpPr txBox="1"/>
+          <p:nvPr/>
+        </p:nvSpPr>
+        <p:spPr>
+          <a:xfrm>
+            <a:off x="457200" y="6400800"/>
+            <a:ext cx="11277295" cy="365760"/>
+          </a:xfrm>
+          <a:prstGeom prst="rect">
+            <a:avLst/>
+          </a:prstGeom>
+          <a:noFill/>
+        </p:spPr>
+        <p:txBody>
+          <a:bodyPr wrap="none">
+            <a:spAutoFit/>
+          </a:bodyPr>
+          <a:lstStyle/>
+          <a:p>
+            <a:pPr>
+              <a:defRPr sz="1100" i="1">
+                <a:solidFill>
+                  <a:srgbClr val="404040"/>
+                </a:solidFill>
+              </a:defRPr>
+            </a:pPr>
+            <a:r>
+              <a:t>✅ = cumprido e verificável no repositório  ·  ⏳ = etapa final de entrega, em andamento</a:t>
             </a:r>
           </a:p>
         </p:txBody>

</xml_diff>